<commit_message>
docs: upload official Cooling Hotlanta pitch deck PPTX and PDF to docs
</commit_message>
<xml_diff>
--- a/docs/ATL-6_Atlanta_Heat_Resilience_Official_Deck.pptx
+++ b/docs/ATL-6_Atlanta_Heat_Resilience_Official_Deck.pptx
@@ -793,61 +793,19 @@
           </a:bodyPr>
           <a:lstStyle/>
           <a:p>
+            <a:pPr indent="0" lvl="0" marL="0" rtl="0" algn="l">
+              <a:spcBef>
+                <a:spcPts val="0"/>
+              </a:spcBef>
+              <a:spcAft>
+                <a:spcPts val="0"/>
+              </a:spcAft>
+              <a:buNone/>
+            </a:pPr>
             <a:r>
-              <a:t>=== SUBMISSION INSTRUCTIONS &amp; COMPETITION CHECKLIST ===</a:t>
+              <a:t/>
             </a:r>
-          </a:p>
-          <a:p/>
-          <a:p>
-            <a:r>
-              <a:t>Official Template: ATL-6 - Google Slides</a:t>
-            </a:r>
-          </a:p>
-          <a:p>
-            <a:r>
-              <a:t>Team ID: ATL-6</a:t>
-            </a:r>
-          </a:p>
-          <a:p>
-            <a:r>
-              <a:t>Challenge 1: Community Climate Resilience (Urban Heat Track)</a:t>
-            </a:r>
-          </a:p>
-          <a:p>
-            <a:r>
-              <a:t>Track: This Budget Cycle (Cooling Center Siting &amp; Infrastructure Investment)</a:t>
-            </a:r>
-          </a:p>
-          <a:p/>
-          <a:p>
-            <a:r>
-              <a:t>Submission Checklist:</a:t>
-            </a:r>
-          </a:p>
-          <a:p>
-            <a:r>
-              <a:t>1. Squad Environment Link: Deployed Cloud Run Agent API &amp; React 18 GIS Dashboard</a:t>
-            </a:r>
-          </a:p>
-          <a:p>
-            <a:r>
-              <a:t>2. Live App / Demo Link: https://atlanta-heat-advisor-frontend-1004921377034.us-central1.run.app</a:t>
-            </a:r>
-          </a:p>
-          <a:p>
-            <a:r>
-              <a:t>3. GitHub Repository: https://github.com/agustincori/A4I2026-challenge-1-walkability</a:t>
-            </a:r>
-          </a:p>
-          <a:p>
-            <a:r>
-              <a:t>4. Recorded Pitch Video: Exactly 3 minutes (0:20 intro, 2:20 demo, 0:20 outro)</a:t>
-            </a:r>
-          </a:p>
-          <a:p>
-            <a:r>
-              <a:t>5. Pitch Deck: 6 required submission slides (Slides 2-7 completely filled out)</a:t>
-            </a:r>
+            <a:endParaRPr/>
           </a:p>
         </p:txBody>
       </p:sp>
@@ -934,51 +892,19 @@
           </a:bodyPr>
           <a:lstStyle/>
           <a:p>
+            <a:pPr indent="0" lvl="0" marL="0" rtl="0" algn="l">
+              <a:spcBef>
+                <a:spcPts val="0"/>
+              </a:spcBef>
+              <a:spcAft>
+                <a:spcPts val="0"/>
+              </a:spcAft>
+              <a:buNone/>
+            </a:pPr>
             <a:r>
-              <a:t>=== SLIDE 2: TITLE &amp; TEAM IDENTIFICATION ===</a:t>
+              <a:t/>
             </a:r>
-          </a:p>
-          <a:p/>
-          <a:p>
-            <a:r>
-              <a:t>Team: ATL-6</a:t>
-            </a:r>
-          </a:p>
-          <a:p>
-            <a:r>
-              <a:t>Solution: Atlanta Urban Climate Resilience &amp; Walkability Advisor</a:t>
-            </a:r>
-          </a:p>
-          <a:p>
-            <a:r>
-              <a:t>Challenge 1: Urban Heat Track (Target Municipality: Atlanta, GA)</a:t>
-            </a:r>
-          </a:p>
-          <a:p>
-            <a:r>
-              <a:t>Live Deployed Dashboard: https://atlanta-heat-advisor-frontend-1004921377034.us-central1.run.app</a:t>
-            </a:r>
-          </a:p>
-          <a:p>
-            <a:r>
-              <a:t>Cloud Run Agent API: https://atlanta-heat-advisor-1004921377034.us-central1.run.app</a:t>
-            </a:r>
-          </a:p>
-          <a:p>
-            <a:r>
-              <a:t>GitHub Repository: https://github.com/agustincori/A4I2026-challenge-1-walkability</a:t>
-            </a:r>
-          </a:p>
-          <a:p/>
-          <a:p>
-            <a:r>
-              <a:t>--- VIDEO WALKTHROUGH INTRO (0:00 - 0:20) ---</a:t>
-            </a:r>
-          </a:p>
-          <a:p>
-            <a:r>
-              <a:t>"Good afternoon, judges. When a heat advisory hits Atlanta, news reports quote KATL Airport: 95°F. But in dense neighborhoods like Sweet Auburn and Peoplestown, microclimates run up to 4.8 degrees hotter. Over 47% of households there have no car, and tree canopy drops below 33%. For Challenge 1's budget track, Dana in the City Manager's office must site 3 permanent cooling centers before tomorrow's 9 AM City Council session. We built the Atlanta Urban Climate Resilience Advisor to solve this with BigQuery ML, pedestrian walk buffers, and an equity audit. Let's see the live tool in action."</a:t>
-            </a:r>
+            <a:endParaRPr/>
           </a:p>
         </p:txBody>
       </p:sp>
@@ -1065,30 +991,19 @@
           </a:bodyPr>
           <a:lstStyle/>
           <a:p>
+            <a:pPr indent="0" lvl="0" marL="0" rtl="0" algn="l">
+              <a:spcBef>
+                <a:spcPts val="0"/>
+              </a:spcBef>
+              <a:spcAft>
+                <a:spcPts val="0"/>
+              </a:spcAft>
+              <a:buNone/>
+            </a:pPr>
             <a:r>
-              <a:t>=== SLIDE 3: TEAM &amp; FILMING AVAILABILITY ===</a:t>
+              <a:t/>
             </a:r>
-          </a:p>
-          <a:p/>
-          <a:p>
-            <a:r>
-              <a:t>Team ID: ATL-6</a:t>
-            </a:r>
-          </a:p>
-          <a:p>
-            <a:r>
-              <a:t>Members: Agustin Corigliano (pagustincorigliano@gmail.com), tshuggler (tshuggler@gmail.com)</a:t>
-            </a:r>
-          </a:p>
-          <a:p>
-            <a:r>
-              <a:t>Filming Availability: Both team members confirm availability to return to Coca-Cola Roxy between 1:00-4:00 PM on Thursday 10/29.</a:t>
-            </a:r>
-          </a:p>
-          <a:p>
-            <a:r>
-              <a:t>Project Sharing: YES - Authorized to share with employer and community partners.</a:t>
-            </a:r>
+            <a:endParaRPr/>
           </a:p>
         </p:txBody>
       </p:sp>
@@ -1175,35 +1090,19 @@
           </a:bodyPr>
           <a:lstStyle/>
           <a:p>
+            <a:pPr indent="0" lvl="0" marL="0" rtl="0" algn="l">
+              <a:spcBef>
+                <a:spcPts val="0"/>
+              </a:spcBef>
+              <a:spcAft>
+                <a:spcPts val="0"/>
+              </a:spcAft>
+              <a:buNone/>
+            </a:pPr>
             <a:r>
-              <a:t>=== SLIDE 4: REAL-WORLD CHALLENGE &amp; SOCIETAL IMPACT ===</a:t>
+              <a:t/>
             </a:r>
-          </a:p>
-          <a:p/>
-          <a:p>
-            <a:r>
-              <a:t>Key Talking Points:</a:t>
-            </a:r>
-          </a:p>
-          <a:p>
-            <a:r>
-              <a:t>1. Airport vs. Street Disparity: Airport readings (95°F) fail to warn residents in asphalt corridors experiencing 99.8°F.</a:t>
-            </a:r>
-          </a:p>
-          <a:p>
-            <a:r>
-              <a:t>2. Transit Dependence: Over 47% of families in Sweet Auburn and Peoplestown do not own cars. Traditional 3-mile regional facilities leave them stranded.</a:t>
-            </a:r>
-          </a:p>
-          <a:p>
-            <a:r>
-              <a:t>3. The Decision Scenario: Dana in the City Manager's Office has $1.2M capital funding and must deliver an unimpeachable council memo by 9:00 AM tomorrow.</a:t>
-            </a:r>
-          </a:p>
-          <a:p>
-            <a:r>
-              <a:t>4. Societal Benefit: Grounding decisions in street-level data ensures public investments flow to historically disinvested, high-vulnerability neighborhoods.</a:t>
-            </a:r>
+            <a:endParaRPr/>
           </a:p>
         </p:txBody>
       </p:sp>
@@ -1290,35 +1189,19 @@
           </a:bodyPr>
           <a:lstStyle/>
           <a:p>
+            <a:pPr indent="0" lvl="0" marL="0" rtl="0" algn="l">
+              <a:spcBef>
+                <a:spcPts val="0"/>
+              </a:spcBef>
+              <a:spcAft>
+                <a:spcPts val="0"/>
+              </a:spcAft>
+              <a:buNone/>
+            </a:pPr>
             <a:r>
-              <a:t>=== SLIDE 5: OUR AGENT &amp; TANGIBLE OUTCOMES ===</a:t>
+              <a:t/>
             </a:r>
-          </a:p>
-          <a:p/>
-          <a:p>
-            <a:r>
-              <a:t>Live Demo Talking Points (0:20 - 1:40):</a:t>
-            </a:r>
-          </a:p>
-          <a:p>
-            <a:r>
-              <a:t>1. Natural Language Interface: Planners talk in street names; the cognitive planner handles geocoding, BQML tool execution, and equity auditing.</a:t>
-            </a:r>
-          </a:p>
-          <a:p>
-            <a:r>
-              <a:t>2. Pedestrian Isochrones: Blue 800-meter walk rings model true sidewalk accessibility rather than naive radial buffers.</a:t>
-            </a:r>
-          </a:p>
-          <a:p>
-            <a:r>
-              <a:t>3. 100% Equity Compliance: Sweet Auburn, South Pryor, and Mechanicsville all exceed the 75th percentile city hardship cutoffs.</a:t>
-            </a:r>
-          </a:p>
-          <a:p>
-            <a:r>
-              <a:t>4. Immediate Policy Adoption: 1-click Council Memo generator eliminates hours of administrative drafting ahead of tomorrow's 9 AM vote.</a:t>
-            </a:r>
+            <a:endParaRPr/>
           </a:p>
         </p:txBody>
       </p:sp>
@@ -1405,30 +1288,19 @@
           </a:bodyPr>
           <a:lstStyle/>
           <a:p>
+            <a:pPr indent="0" lvl="0" marL="0" rtl="0" algn="l">
+              <a:spcBef>
+                <a:spcPts val="0"/>
+              </a:spcBef>
+              <a:spcAft>
+                <a:spcPts val="0"/>
+              </a:spcAft>
+              <a:buNone/>
+            </a:pPr>
             <a:r>
-              <a:t>=== SLIDE 6: DATA ECOSYSTEM &amp; ETHICAL RIGOR ===</a:t>
+              <a:t/>
             </a:r>
-          </a:p>
-          <a:p/>
-          <a:p>
-            <a:r>
-              <a:t>Technical Rigor &amp; Limitations (1:40 - 2:10):</a:t>
-            </a:r>
-          </a:p>
-          <a:p>
-            <a:r>
-              <a:t>1. Offset vs Raw Temp: Predicting thermal offset isolates permanent urban fabric from day-to-day weather fluctuations.</a:t>
-            </a:r>
-          </a:p>
-          <a:p>
-            <a:r>
-              <a:t>2. Bias Exclusion: Strict exclusion of race/ethnicity in training features prevents machine learning from codifying historical segregation.</a:t>
-            </a:r>
-          </a:p>
-          <a:p>
-            <a:r>
-              <a:t>3. Honest Constraints: NOAA Heat Watch captures one representative summer day; multi-year variance requires longitudinal satellite calibration. We diagnose root causes (+2.4°F canopy deficit), but do not claim to simulate future tree growth without biological models.</a:t>
-            </a:r>
+            <a:endParaRPr/>
           </a:p>
         </p:txBody>
       </p:sp>
@@ -1515,46 +1387,19 @@
           </a:bodyPr>
           <a:lstStyle/>
           <a:p>
+            <a:pPr indent="0" lvl="0" marL="0" rtl="0" algn="l">
+              <a:spcBef>
+                <a:spcPts val="0"/>
+              </a:spcBef>
+              <a:spcAft>
+                <a:spcPts val="0"/>
+              </a:spcAft>
+              <a:buNone/>
+            </a:pPr>
             <a:r>
-              <a:t>=== SLIDE 7: ARCHITECTURE TOUR &amp; 3-CLOCK OUTRO ===</a:t>
+              <a:t/>
             </a:r>
-          </a:p>
-          <a:p/>
-          <a:p>
-            <a:r>
-              <a:t>Architecture Tour (2:10 - 2:40):</a:t>
-            </a:r>
-          </a:p>
-          <a:p>
-            <a:r>
-              <a:t>• Gemini 2.5 Flash on Vertex AI via Google ADK runtime.</a:t>
-            </a:r>
-          </a:p>
-          <a:p>
-            <a:r>
-              <a:t>• BigQuery ML heat_offset_model running in Google Cloud data plane.</a:t>
-            </a:r>
-          </a:p>
-          <a:p>
-            <a:r>
-              <a:t>• Serverless Cloud Run endpoint live at atlanta-heat-advisor-1004921377034.us-central1.run.app.</a:t>
-            </a:r>
-          </a:p>
-          <a:p>
-            <a:r>
-              <a:t>• React 18 + Leaflet GIS dashboard with zero CORS errors via Vite proxy.</a:t>
-            </a:r>
-          </a:p>
-          <a:p/>
-          <a:p>
-            <a:r>
-              <a:t>20-Second Outro (2:40 - 3:00):</a:t>
-            </a:r>
-          </a:p>
-          <a:p>
-            <a:r>
-              <a:t>"To wrap up: our advisor gives Atlanta leaders an actionable, defensible path across all three clocks. Tomorrow, emergency hydration vans to Sweet Auburn. This budget cycle, 42 MARTA transit shade structures. And this decade, urban canopy planting at the bottom 20% tracts. By connecting BigQuery ML with street-level walkability and an uncompromising equity audit, we ensure no neighborhood is left behind. Thank you."</a:t>
-            </a:r>
+            <a:endParaRPr/>
           </a:p>
         </p:txBody>
       </p:sp>
@@ -11656,61 +11501,15 @@
           </a:bodyPr>
           <a:lstStyle/>
           <a:p>
-            <a:pPr indent="0" lvl="0" marL="0" rtl="0" algn="ctr">
-              <a:lnSpc>
-                <a:spcPct val="90000"/>
-              </a:lnSpc>
-              <a:spcBef>
-                <a:spcPts val="0"/>
-              </a:spcBef>
-              <a:spcAft>
-                <a:spcPts val="0"/>
-              </a:spcAft>
-              <a:buNone/>
+            <a:pPr algn="l">
               <a:defRPr sz="2800" b="1">
                 <a:solidFill>
-                  <a:srgbClr val="202124"/>
+                  <a:srgbClr val="FFFFFF"/>
                 </a:solidFill>
-                <a:latin typeface="Google Sans Flex Medium"/>
               </a:defRPr>
             </a:pPr>
             <a:r>
-              <a:t>ATL-6</a:t>
-            </a:r>
-            <a:endParaRPr sz="2400">
-              <a:solidFill>
-                <a:schemeClr val="lt1"/>
-              </a:solidFill>
-              <a:latin typeface="Google Sans Flex Medium"/>
-              <a:ea typeface="Google Sans Flex Medium"/>
-              <a:cs typeface="Google Sans Flex Medium"/>
-              <a:sym typeface="Google Sans Flex Medium"/>
-            </a:endParaRPr>
-          </a:p>
-          <a:p>
-            <a:pPr>
-              <a:defRPr sz="1300" b="1">
-                <a:solidFill>
-                  <a:srgbClr val="1A73E8"/>
-                </a:solidFill>
-                <a:latin typeface="Google Sans Flex"/>
-              </a:defRPr>
-            </a:pPr>
-            <a:r>
-              <a:t>Atlanta Urban Climate Resilience Advisor</a:t>
-            </a:r>
-          </a:p>
-          <a:p>
-            <a:pPr>
-              <a:defRPr sz="1000">
-                <a:solidFill>
-                  <a:srgbClr val="5F6368"/>
-                </a:solidFill>
-                <a:latin typeface="Google Sans Flex"/>
-              </a:defRPr>
-            </a:pPr>
-            <a:r>
-              <a:t>Challenge 1: Urban Heat • Track: This Budget Cycle</a:t>
+              <a:t>Cooling Hotlanta</a:t>
             </a:r>
           </a:p>
         </p:txBody>
@@ -11742,65 +11541,6 @@
           </a:ln>
         </p:spPr>
       </p:pic>
-      <p:sp>
-        <p:nvSpPr>
-          <p:cNvPr id="121" name="TextBox 120"/>
-          <p:cNvSpPr txBox="1"/>
-          <p:nvPr/>
-        </p:nvSpPr>
-        <p:spPr>
-          <a:xfrm>
-            <a:off x="3584448" y="3611880"/>
-            <a:ext cx="5120640" cy="1097280"/>
-          </a:xfrm>
-          <a:prstGeom prst="rect">
-            <a:avLst/>
-          </a:prstGeom>
-          <a:noFill/>
-        </p:spPr>
-        <p:txBody>
-          <a:bodyPr wrap="square">
-            <a:spAutoFit/>
-          </a:bodyPr>
-          <a:lstStyle/>
-          <a:p>
-            <a:pPr>
-              <a:defRPr sz="900">
-                <a:solidFill>
-                  <a:srgbClr val="202124"/>
-                </a:solidFill>
-              </a:defRPr>
-            </a:pPr>
-            <a:r>
-              <a:t>• Live Dashboard: atlanta-heat-advisor-frontend-1004921377034.us-central1.run.app</a:t>
-            </a:r>
-          </a:p>
-          <a:p>
-            <a:pPr>
-              <a:defRPr sz="900">
-                <a:solidFill>
-                  <a:srgbClr val="202124"/>
-                </a:solidFill>
-              </a:defRPr>
-            </a:pPr>
-            <a:r>
-              <a:t>• Agent API (Cloud Run): atlanta-heat-advisor-1004921377034.us-central1.run.app</a:t>
-            </a:r>
-          </a:p>
-          <a:p>
-            <a:pPr>
-              <a:defRPr sz="900">
-                <a:solidFill>
-                  <a:srgbClr val="202124"/>
-                </a:solidFill>
-              </a:defRPr>
-            </a:pPr>
-            <a:r>
-              <a:t>• GitHub: github.com/agustincori/A4I2026-challenge-1-walkability</a:t>
-            </a:r>
-          </a:p>
-        </p:txBody>
-      </p:sp>
     </p:spTree>
   </p:cSld>
   <p:clrMapOvr>
@@ -12417,12 +12157,14 @@
                     <a:lstStyle/>
                     <a:p>
                       <a:pPr>
-                        <a:defRPr sz="850">
-                          <a:latin typeface="Google Sans Flex"/>
+                        <a:defRPr sz="950">
+                          <a:solidFill>
+                            <a:srgbClr val="FFFFFF"/>
+                          </a:solidFill>
                         </a:defRPr>
                       </a:pPr>
                       <a:r>
-                        <a:t>Agustin Corigliano</a:t>
+                        <a:t>Tanya Huggler</a:t>
                       </a:r>
                     </a:p>
                   </a:txBody>
@@ -12471,12 +12213,14 @@
                     <a:lstStyle/>
                     <a:p>
                       <a:pPr>
-                        <a:defRPr sz="850">
-                          <a:latin typeface="Google Sans Flex"/>
+                        <a:defRPr sz="950">
+                          <a:solidFill>
+                            <a:srgbClr val="FFFFFF"/>
+                          </a:solidFill>
                         </a:defRPr>
                       </a:pPr>
                       <a:r>
-                        <a:t>pagustincorigliano@gmail.com</a:t>
+                        <a:t>tanya.huggler@coxautoinc.com</a:t>
                       </a:r>
                     </a:p>
                   </a:txBody>
@@ -12525,12 +12269,14 @@
                     <a:lstStyle/>
                     <a:p>
                       <a:pPr>
-                        <a:defRPr sz="850">
-                          <a:latin typeface="Google Sans Flex"/>
+                        <a:defRPr sz="950">
+                          <a:solidFill>
+                            <a:srgbClr val="FFFFFF"/>
+                          </a:solidFill>
                         </a:defRPr>
                       </a:pPr>
                       <a:r>
-                        <a:t>[On File / Discord]</a:t>
+                        <a:t>518-542-5335</a:t>
                       </a:r>
                     </a:p>
                   </a:txBody>
@@ -12579,12 +12325,14 @@
                     <a:lstStyle/>
                     <a:p>
                       <a:pPr>
-                        <a:defRPr sz="850">
-                          <a:latin typeface="Google Sans Flex"/>
+                        <a:defRPr sz="950">
+                          <a:solidFill>
+                            <a:srgbClr val="FFFFFF"/>
+                          </a:solidFill>
                         </a:defRPr>
                       </a:pPr>
                       <a:r>
-                        <a:t>Yes (1:00-4:00 PM on 10/29)</a:t>
+                        <a:t>1:00</a:t>
                       </a:r>
                     </a:p>
                   </a:txBody>
@@ -12633,13 +12381,12 @@
                     <a:lstStyle/>
                     <a:p>
                       <a:pPr>
-                        <a:defRPr sz="850">
-                          <a:latin typeface="Google Sans Flex"/>
+                        <a:defRPr sz="950">
+                          <a:solidFill>
+                            <a:srgbClr val="FFFFFF"/>
+                          </a:solidFill>
                         </a:defRPr>
                       </a:pPr>
-                      <a:r>
-                        <a:t>Yes</a:t>
-                      </a:r>
                     </a:p>
                   </a:txBody>
                   <a:tcPr marT="19050" marB="19050" marR="28575" marL="28575">
@@ -12687,13 +12434,12 @@
                     <a:lstStyle/>
                     <a:p>
                       <a:pPr>
-                        <a:defRPr sz="850">
-                          <a:latin typeface="Google Sans Flex"/>
+                        <a:defRPr sz="950">
+                          <a:solidFill>
+                            <a:srgbClr val="FFFFFF"/>
+                          </a:solidFill>
                         </a:defRPr>
                       </a:pPr>
-                      <a:r>
-                        <a:t>team@agentsforimpact.org</a:t>
-                      </a:r>
                     </a:p>
                   </a:txBody>
                   <a:tcPr marT="91425" marB="91425" marR="91425" marL="91425">
@@ -12743,12 +12489,14 @@
                     <a:lstStyle/>
                     <a:p>
                       <a:pPr>
-                        <a:defRPr sz="850">
-                          <a:latin typeface="Google Sans Flex"/>
+                        <a:defRPr sz="950">
+                          <a:solidFill>
+                            <a:srgbClr val="FFFFFF"/>
+                          </a:solidFill>
                         </a:defRPr>
                       </a:pPr>
                       <a:r>
-                        <a:t>tshuggler</a:t>
+                        <a:t>Agustin Corigliano</a:t>
                       </a:r>
                     </a:p>
                   </a:txBody>
@@ -12797,12 +12545,14 @@
                     <a:lstStyle/>
                     <a:p>
                       <a:pPr>
-                        <a:defRPr sz="850">
-                          <a:latin typeface="Google Sans Flex"/>
+                        <a:defRPr sz="950">
+                          <a:solidFill>
+                            <a:srgbClr val="FFFFFF"/>
+                          </a:solidFill>
                         </a:defRPr>
                       </a:pPr>
                       <a:r>
-                        <a:t>tshuggler@gmail.com</a:t>
+                        <a:t>pagustincorigliano@gmail.com</a:t>
                       </a:r>
                     </a:p>
                   </a:txBody>
@@ -12851,12 +12601,14 @@
                     <a:lstStyle/>
                     <a:p>
                       <a:pPr>
-                        <a:defRPr sz="850">
-                          <a:latin typeface="Google Sans Flex"/>
+                        <a:defRPr sz="950">
+                          <a:solidFill>
+                            <a:srgbClr val="FFFFFF"/>
+                          </a:solidFill>
                         </a:defRPr>
                       </a:pPr>
                       <a:r>
-                        <a:t>[On File / Discord]</a:t>
+                        <a:t>786-721-3109</a:t>
                       </a:r>
                     </a:p>
                   </a:txBody>
@@ -12905,12 +12657,14 @@
                     <a:lstStyle/>
                     <a:p>
                       <a:pPr>
-                        <a:defRPr sz="850">
-                          <a:latin typeface="Google Sans Flex"/>
+                        <a:defRPr sz="950">
+                          <a:solidFill>
+                            <a:srgbClr val="FFFFFF"/>
+                          </a:solidFill>
                         </a:defRPr>
                       </a:pPr>
                       <a:r>
-                        <a:t>Yes (1:00-4:00 PM on 10/29)</a:t>
+                        <a:t>1:00</a:t>
                       </a:r>
                     </a:p>
                   </a:txBody>
@@ -12959,13 +12713,12 @@
                     <a:lstStyle/>
                     <a:p>
                       <a:pPr>
-                        <a:defRPr sz="850">
-                          <a:latin typeface="Google Sans Flex"/>
+                        <a:defRPr sz="950">
+                          <a:solidFill>
+                            <a:srgbClr val="FFFFFF"/>
+                          </a:solidFill>
                         </a:defRPr>
                       </a:pPr>
-                      <a:r>
-                        <a:t>Yes</a:t>
-                      </a:r>
                     </a:p>
                   </a:txBody>
                   <a:tcPr marT="19050" marB="19050" marR="28575" marL="28575">
@@ -13013,13 +12766,12 @@
                     <a:lstStyle/>
                     <a:p>
                       <a:pPr>
-                        <a:defRPr sz="850">
-                          <a:latin typeface="Google Sans Flex"/>
+                        <a:defRPr sz="950">
+                          <a:solidFill>
+                            <a:srgbClr val="FFFFFF"/>
+                          </a:solidFill>
                         </a:defRPr>
                       </a:pPr>
-                      <a:r>
-                        <a:t>team@agentsforimpact.org</a:t>
-                      </a:r>
                     </a:p>
                   </a:txBody>
                   <a:tcPr marT="91425" marB="91425" marR="91425" marL="91425">
@@ -13068,19 +12820,16 @@
                     <a:bodyPr/>
                     <a:lstStyle/>
                     <a:p>
-                      <a:pPr indent="0" lvl="0" marL="0" rtl="0" algn="l">
-                        <a:spcBef>
-                          <a:spcPts val="0"/>
-                        </a:spcBef>
-                        <a:spcAft>
-                          <a:spcPts val="0"/>
-                        </a:spcAft>
-                        <a:buNone/>
+                      <a:pPr>
+                        <a:defRPr sz="950">
+                          <a:solidFill>
+                            <a:srgbClr val="FFFFFF"/>
+                          </a:solidFill>
+                        </a:defRPr>
                       </a:pPr>
                       <a:r>
-                        <a:t/>
+                        <a:t>Joel Metuge</a:t>
                       </a:r>
-                      <a:endParaRPr/>
                     </a:p>
                   </a:txBody>
                   <a:tcPr marT="91425" marB="91425" marR="91425" marL="91425">
@@ -13127,19 +12876,16 @@
                     <a:bodyPr/>
                     <a:lstStyle/>
                     <a:p>
-                      <a:pPr indent="0" lvl="0" marL="0" rtl="0" algn="l">
-                        <a:spcBef>
-                          <a:spcPts val="0"/>
-                        </a:spcBef>
-                        <a:spcAft>
-                          <a:spcPts val="0"/>
-                        </a:spcAft>
-                        <a:buNone/>
+                      <a:pPr>
+                        <a:defRPr sz="950">
+                          <a:solidFill>
+                            <a:srgbClr val="FFFFFF"/>
+                          </a:solidFill>
+                        </a:defRPr>
                       </a:pPr>
                       <a:r>
-                        <a:t/>
+                        <a:t>joelmetuge0707@gmail.com</a:t>
                       </a:r>
-                      <a:endParaRPr/>
                     </a:p>
                   </a:txBody>
                   <a:tcPr marT="91425" marB="91425" marR="91425" marL="91425">
@@ -13186,19 +12932,16 @@
                     <a:bodyPr/>
                     <a:lstStyle/>
                     <a:p>
-                      <a:pPr indent="0" lvl="0" marL="0" rtl="0" algn="l">
-                        <a:spcBef>
-                          <a:spcPts val="0"/>
-                        </a:spcBef>
-                        <a:spcAft>
-                          <a:spcPts val="0"/>
-                        </a:spcAft>
-                        <a:buNone/>
+                      <a:pPr>
+                        <a:defRPr sz="950">
+                          <a:solidFill>
+                            <a:srgbClr val="FFFFFF"/>
+                          </a:solidFill>
+                        </a:defRPr>
                       </a:pPr>
                       <a:r>
-                        <a:t/>
+                        <a:t>256-797-2970</a:t>
                       </a:r>
-                      <a:endParaRPr/>
                     </a:p>
                   </a:txBody>
                   <a:tcPr marT="91425" marB="91425" marR="91425" marL="91425">
@@ -13245,23 +12988,16 @@
                     <a:bodyPr/>
                     <a:lstStyle/>
                     <a:p>
-                      <a:pPr indent="0" lvl="0" marL="0" rtl="0" algn="l">
-                        <a:spcBef>
-                          <a:spcPts val="0"/>
-                        </a:spcBef>
-                        <a:spcAft>
-                          <a:spcPts val="0"/>
-                        </a:spcAft>
-                        <a:buNone/>
+                      <a:pPr>
+                        <a:defRPr sz="950">
+                          <a:solidFill>
+                            <a:srgbClr val="FFFFFF"/>
+                          </a:solidFill>
+                        </a:defRPr>
                       </a:pPr>
                       <a:r>
-                        <a:t/>
+                        <a:t>1:00</a:t>
                       </a:r>
-                      <a:endParaRPr>
-                        <a:solidFill>
-                          <a:schemeClr val="lt1"/>
-                        </a:solidFill>
-                      </a:endParaRPr>
                     </a:p>
                   </a:txBody>
                   <a:tcPr marT="19050" marB="19050" marR="28575" marL="28575">
@@ -13308,23 +13044,13 @@
                     <a:bodyPr/>
                     <a:lstStyle/>
                     <a:p>
-                      <a:pPr indent="0" lvl="0" marL="0" rtl="0" algn="l">
-                        <a:spcBef>
-                          <a:spcPts val="0"/>
-                        </a:spcBef>
-                        <a:spcAft>
-                          <a:spcPts val="0"/>
-                        </a:spcAft>
-                        <a:buNone/>
+                      <a:pPr>
+                        <a:defRPr sz="950">
+                          <a:solidFill>
+                            <a:srgbClr val="FFFFFF"/>
+                          </a:solidFill>
+                        </a:defRPr>
                       </a:pPr>
-                      <a:r>
-                        <a:t/>
-                      </a:r>
-                      <a:endParaRPr>
-                        <a:solidFill>
-                          <a:schemeClr val="lt1"/>
-                        </a:solidFill>
-                      </a:endParaRPr>
                     </a:p>
                   </a:txBody>
                   <a:tcPr marT="19050" marB="19050" marR="28575" marL="28575">
@@ -13371,19 +13097,13 @@
                     <a:bodyPr/>
                     <a:lstStyle/>
                     <a:p>
-                      <a:pPr indent="0" lvl="0" marL="0" rtl="0" algn="l">
-                        <a:spcBef>
-                          <a:spcPts val="0"/>
-                        </a:spcBef>
-                        <a:spcAft>
-                          <a:spcPts val="0"/>
-                        </a:spcAft>
-                        <a:buNone/>
+                      <a:pPr>
+                        <a:defRPr sz="950">
+                          <a:solidFill>
+                            <a:srgbClr val="FFFFFF"/>
+                          </a:solidFill>
+                        </a:defRPr>
                       </a:pPr>
-                      <a:r>
-                        <a:t/>
-                      </a:r>
-                      <a:endParaRPr/>
                     </a:p>
                   </a:txBody>
                   <a:tcPr marT="91425" marB="91425" marR="91425" marL="91425">
@@ -13432,19 +13152,16 @@
                     <a:bodyPr/>
                     <a:lstStyle/>
                     <a:p>
-                      <a:pPr indent="0" lvl="0" marL="0" rtl="0" algn="l">
-                        <a:spcBef>
-                          <a:spcPts val="0"/>
-                        </a:spcBef>
-                        <a:spcAft>
-                          <a:spcPts val="0"/>
-                        </a:spcAft>
-                        <a:buNone/>
+                      <a:pPr>
+                        <a:defRPr sz="950">
+                          <a:solidFill>
+                            <a:srgbClr val="FFFFFF"/>
+                          </a:solidFill>
+                        </a:defRPr>
                       </a:pPr>
                       <a:r>
-                        <a:t/>
+                        <a:t>David Ballagh</a:t>
                       </a:r>
-                      <a:endParaRPr/>
                     </a:p>
                   </a:txBody>
                   <a:tcPr marT="91425" marB="91425" marR="91425" marL="91425">
@@ -13491,19 +13208,16 @@
                     <a:bodyPr/>
                     <a:lstStyle/>
                     <a:p>
-                      <a:pPr indent="0" lvl="0" marL="0" rtl="0" algn="l">
-                        <a:spcBef>
-                          <a:spcPts val="0"/>
-                        </a:spcBef>
-                        <a:spcAft>
-                          <a:spcPts val="0"/>
-                        </a:spcAft>
-                        <a:buNone/>
+                      <a:pPr>
+                        <a:defRPr sz="950">
+                          <a:solidFill>
+                            <a:srgbClr val="FFFFFF"/>
+                          </a:solidFill>
+                        </a:defRPr>
                       </a:pPr>
                       <a:r>
-                        <a:t/>
+                        <a:t>david.ballagh@gmail.com</a:t>
                       </a:r>
-                      <a:endParaRPr/>
                     </a:p>
                   </a:txBody>
                   <a:tcPr marT="91425" marB="91425" marR="91425" marL="91425">
@@ -13550,19 +13264,16 @@
                     <a:bodyPr/>
                     <a:lstStyle/>
                     <a:p>
-                      <a:pPr indent="0" lvl="0" marL="0" rtl="0" algn="l">
-                        <a:spcBef>
-                          <a:spcPts val="0"/>
-                        </a:spcBef>
-                        <a:spcAft>
-                          <a:spcPts val="0"/>
-                        </a:spcAft>
-                        <a:buNone/>
+                      <a:pPr>
+                        <a:defRPr sz="950">
+                          <a:solidFill>
+                            <a:srgbClr val="FFFFFF"/>
+                          </a:solidFill>
+                        </a:defRPr>
                       </a:pPr>
                       <a:r>
-                        <a:t/>
+                        <a:t>352-978-8537</a:t>
                       </a:r>
-                      <a:endParaRPr/>
                     </a:p>
                   </a:txBody>
                   <a:tcPr marT="91425" marB="91425" marR="91425" marL="91425">
@@ -13609,23 +13320,16 @@
                     <a:bodyPr/>
                     <a:lstStyle/>
                     <a:p>
-                      <a:pPr indent="0" lvl="0" marL="0" rtl="0" algn="l">
-                        <a:spcBef>
-                          <a:spcPts val="0"/>
-                        </a:spcBef>
-                        <a:spcAft>
-                          <a:spcPts val="0"/>
-                        </a:spcAft>
-                        <a:buNone/>
+                      <a:pPr>
+                        <a:defRPr sz="950">
+                          <a:solidFill>
+                            <a:srgbClr val="FFFFFF"/>
+                          </a:solidFill>
+                        </a:defRPr>
                       </a:pPr>
                       <a:r>
-                        <a:t/>
+                        <a:t>1:00</a:t>
                       </a:r>
-                      <a:endParaRPr>
-                        <a:solidFill>
-                          <a:schemeClr val="lt1"/>
-                        </a:solidFill>
-                      </a:endParaRPr>
                     </a:p>
                   </a:txBody>
                   <a:tcPr marT="19050" marB="19050" marR="28575" marL="28575">
@@ -13672,23 +13376,13 @@
                     <a:bodyPr/>
                     <a:lstStyle/>
                     <a:p>
-                      <a:pPr indent="0" lvl="0" marL="0" rtl="0" algn="l">
-                        <a:spcBef>
-                          <a:spcPts val="0"/>
-                        </a:spcBef>
-                        <a:spcAft>
-                          <a:spcPts val="0"/>
-                        </a:spcAft>
-                        <a:buNone/>
+                      <a:pPr>
+                        <a:defRPr sz="950">
+                          <a:solidFill>
+                            <a:srgbClr val="FFFFFF"/>
+                          </a:solidFill>
+                        </a:defRPr>
                       </a:pPr>
-                      <a:r>
-                        <a:t/>
-                      </a:r>
-                      <a:endParaRPr>
-                        <a:solidFill>
-                          <a:schemeClr val="lt1"/>
-                        </a:solidFill>
-                      </a:endParaRPr>
                     </a:p>
                   </a:txBody>
                   <a:tcPr marT="19050" marB="19050" marR="28575" marL="28575">
@@ -13735,19 +13429,13 @@
                     <a:bodyPr/>
                     <a:lstStyle/>
                     <a:p>
-                      <a:pPr indent="0" lvl="0" marL="0" rtl="0" algn="l">
-                        <a:spcBef>
-                          <a:spcPts val="0"/>
-                        </a:spcBef>
-                        <a:spcAft>
-                          <a:spcPts val="0"/>
-                        </a:spcAft>
-                        <a:buNone/>
+                      <a:pPr>
+                        <a:defRPr sz="950">
+                          <a:solidFill>
+                            <a:srgbClr val="FFFFFF"/>
+                          </a:solidFill>
+                        </a:defRPr>
                       </a:pPr>
-                      <a:r>
-                        <a:t/>
-                      </a:r>
-                      <a:endParaRPr/>
                     </a:p>
                   </a:txBody>
                   <a:tcPr marT="91425" marB="91425" marR="91425" marL="91425">
@@ -13796,19 +13484,16 @@
                     <a:bodyPr/>
                     <a:lstStyle/>
                     <a:p>
-                      <a:pPr indent="0" lvl="0" marL="0" rtl="0" algn="l">
-                        <a:spcBef>
-                          <a:spcPts val="0"/>
-                        </a:spcBef>
-                        <a:spcAft>
-                          <a:spcPts val="0"/>
-                        </a:spcAft>
-                        <a:buNone/>
+                      <a:pPr>
+                        <a:defRPr sz="950">
+                          <a:solidFill>
+                            <a:srgbClr val="FFFFFF"/>
+                          </a:solidFill>
+                        </a:defRPr>
                       </a:pPr>
                       <a:r>
-                        <a:t/>
+                        <a:t>Vamshi Gangula</a:t>
                       </a:r>
-                      <a:endParaRPr/>
                     </a:p>
                   </a:txBody>
                   <a:tcPr marT="91425" marB="91425" marR="91425" marL="91425">
@@ -13855,19 +13540,16 @@
                     <a:bodyPr/>
                     <a:lstStyle/>
                     <a:p>
-                      <a:pPr indent="0" lvl="0" marL="0" rtl="0" algn="l">
-                        <a:spcBef>
-                          <a:spcPts val="0"/>
-                        </a:spcBef>
-                        <a:spcAft>
-                          <a:spcPts val="0"/>
-                        </a:spcAft>
-                        <a:buNone/>
+                      <a:pPr>
+                        <a:defRPr sz="950">
+                          <a:solidFill>
+                            <a:srgbClr val="FFFFFF"/>
+                          </a:solidFill>
+                        </a:defRPr>
                       </a:pPr>
                       <a:r>
-                        <a:t/>
+                        <a:t>vkgangula@gmail.com</a:t>
                       </a:r>
-                      <a:endParaRPr/>
                     </a:p>
                   </a:txBody>
                   <a:tcPr marT="91425" marB="91425" marR="91425" marL="91425">
@@ -13914,19 +13596,16 @@
                     <a:bodyPr/>
                     <a:lstStyle/>
                     <a:p>
-                      <a:pPr indent="0" lvl="0" marL="0" rtl="0" algn="l">
-                        <a:spcBef>
-                          <a:spcPts val="0"/>
-                        </a:spcBef>
-                        <a:spcAft>
-                          <a:spcPts val="0"/>
-                        </a:spcAft>
-                        <a:buNone/>
+                      <a:pPr>
+                        <a:defRPr sz="950">
+                          <a:solidFill>
+                            <a:srgbClr val="FFFFFF"/>
+                          </a:solidFill>
+                        </a:defRPr>
                       </a:pPr>
                       <a:r>
-                        <a:t/>
+                        <a:t>503-726-8746</a:t>
                       </a:r>
-                      <a:endParaRPr/>
                     </a:p>
                   </a:txBody>
                   <a:tcPr marT="91425" marB="91425" marR="91425" marL="91425">
@@ -13973,23 +13652,16 @@
                     <a:bodyPr/>
                     <a:lstStyle/>
                     <a:p>
-                      <a:pPr indent="0" lvl="0" marL="0" rtl="0" algn="l">
-                        <a:spcBef>
-                          <a:spcPts val="0"/>
-                        </a:spcBef>
-                        <a:spcAft>
-                          <a:spcPts val="0"/>
-                        </a:spcAft>
-                        <a:buNone/>
+                      <a:pPr>
+                        <a:defRPr sz="950">
+                          <a:solidFill>
+                            <a:srgbClr val="FFFFFF"/>
+                          </a:solidFill>
+                        </a:defRPr>
                       </a:pPr>
                       <a:r>
-                        <a:t/>
+                        <a:t>1:00</a:t>
                       </a:r>
-                      <a:endParaRPr>
-                        <a:solidFill>
-                          <a:schemeClr val="lt1"/>
-                        </a:solidFill>
-                      </a:endParaRPr>
                     </a:p>
                   </a:txBody>
                   <a:tcPr marT="19050" marB="19050" marR="28575" marL="28575">
@@ -14036,23 +13708,13 @@
                     <a:bodyPr/>
                     <a:lstStyle/>
                     <a:p>
-                      <a:pPr indent="0" lvl="0" marL="0" rtl="0" algn="l">
-                        <a:spcBef>
-                          <a:spcPts val="0"/>
-                        </a:spcBef>
-                        <a:spcAft>
-                          <a:spcPts val="0"/>
-                        </a:spcAft>
-                        <a:buNone/>
+                      <a:pPr>
+                        <a:defRPr sz="950">
+                          <a:solidFill>
+                            <a:srgbClr val="FFFFFF"/>
+                          </a:solidFill>
+                        </a:defRPr>
                       </a:pPr>
-                      <a:r>
-                        <a:t/>
-                      </a:r>
-                      <a:endParaRPr>
-                        <a:solidFill>
-                          <a:schemeClr val="lt1"/>
-                        </a:solidFill>
-                      </a:endParaRPr>
                     </a:p>
                   </a:txBody>
                   <a:tcPr marT="19050" marB="19050" marR="28575" marL="28575">
@@ -14099,19 +13761,13 @@
                     <a:bodyPr/>
                     <a:lstStyle/>
                     <a:p>
-                      <a:pPr indent="0" lvl="0" marL="0" rtl="0" algn="l">
-                        <a:spcBef>
-                          <a:spcPts val="0"/>
-                        </a:spcBef>
-                        <a:spcAft>
-                          <a:spcPts val="0"/>
-                        </a:spcAft>
-                        <a:buNone/>
+                      <a:pPr>
+                        <a:defRPr sz="950">
+                          <a:solidFill>
+                            <a:srgbClr val="FFFFFF"/>
+                          </a:solidFill>
+                        </a:defRPr>
                       </a:pPr>
-                      <a:r>
-                        <a:t/>
-                      </a:r>
-                      <a:endParaRPr/>
                     </a:p>
                   </a:txBody>
                   <a:tcPr marT="91425" marB="91425" marR="91425" marL="91425">
@@ -15653,8 +15309,8 @@
         </p:nvSpPr>
         <p:spPr>
           <a:xfrm>
-            <a:off x="1097280" y="1371600"/>
-            <a:ext cx="6949440" cy="3291840"/>
+            <a:off x="2769600" y="2637075"/>
+            <a:ext cx="3604800" cy="2071800"/>
           </a:xfrm>
           <a:prstGeom prst="rect">
             <a:avLst/>
@@ -15678,18 +15334,17 @@
                 <a:spcPts val="1200"/>
               </a:spcBef>
               <a:spcAft>
-                <a:spcPts val="300"/>
-              </a:spcAft>
-              <a:buNone/>
-              <a:defRPr b="1" sz="1300">
+                <a:spcPts val="400"/>
+              </a:spcAft>
+              <a:buNone/>
+              <a:defRPr sz="1400" b="1">
                 <a:solidFill>
-                  <a:srgbClr val="D93025"/>
+                  <a:srgbClr val="FFFFFF"/>
                 </a:solidFill>
-                <a:latin typeface="Google Sans Flex Medium"/>
               </a:defRPr>
             </a:pPr>
             <a:r>
-              <a:t>⚠️ Real-World Challenge: Atlanta's Urban Heat Disparity</a:t>
+              <a:t>Real-world challenge</a:t>
             </a:r>
             <a:endParaRPr sz="1200">
               <a:solidFill>
@@ -15698,119 +15353,45 @@
             </a:endParaRPr>
           </a:p>
           <a:p>
-            <a:pPr>
-              <a:spcAft>
-                <a:spcPts val="300"/>
-              </a:spcAft>
+            <a:pPr algn="ctr">
+              <a:spcAft>
+                <a:spcPts val="2400"/>
+              </a:spcAft>
+              <a:defRPr sz="1300">
+                <a:solidFill>
+                  <a:srgbClr val="FFFFFF"/>
+                </a:solidFill>
+              </a:defRPr>
             </a:pPr>
             <a:r>
-              <a:rPr b="1" sz="950">
-                <a:solidFill>
-                  <a:srgbClr val="202124"/>
-                </a:solidFill>
-                <a:latin typeface="Google Sans Flex"/>
-              </a:rPr>
-              <a:t>• The Airport Forecast Fallacy: </a:t>
-            </a:r>
-            <a:r>
-              <a:rPr sz="950">
-                <a:solidFill>
-                  <a:srgbClr val="202124"/>
-                </a:solidFill>
-                <a:latin typeface="Google Sans Flex"/>
-              </a:rPr>
-              <a:t>Regional forecasts quote KATL Airport (95°F), hiding lethal street-level microclimates running up to +4.77°F hotter in dense asphalt corridors like Sweet Auburn.</a:t>
+              <a:t>Severe urban heat islands threatening public health across vulnerable, tree-deprived Atlanta neighborhoods.</a:t>
             </a:r>
           </a:p>
           <a:p>
-            <a:pPr>
-              <a:spcAft>
-                <a:spcPts val="300"/>
-              </a:spcAft>
+            <a:pPr algn="ctr">
+              <a:spcAft>
+                <a:spcPts val="400"/>
+              </a:spcAft>
+              <a:defRPr sz="1400" b="1">
+                <a:solidFill>
+                  <a:srgbClr val="FFFFFF"/>
+                </a:solidFill>
+              </a:defRPr>
             </a:pPr>
             <a:r>
-              <a:rPr b="1" sz="950">
-                <a:solidFill>
-                  <a:srgbClr val="202124"/>
-                </a:solidFill>
-                <a:latin typeface="Google Sans Flex"/>
-              </a:rPr>
-              <a:t>• Severe Transit &amp; Canopy Deprivation: </a:t>
-            </a:r>
-            <a:r>
-              <a:rPr sz="950">
-                <a:solidFill>
-                  <a:srgbClr val="202124"/>
-                </a:solidFill>
-                <a:latin typeface="Google Sans Flex"/>
-              </a:rPr>
-              <a:t>In the hottest census tracts, &gt;47% of households have no vehicle and tree canopy drops below 33%. Residents cannot walk or drive miles across town to regional cooling centers.</a:t>
+              <a:t>Details</a:t>
             </a:r>
           </a:p>
           <a:p>
-            <a:pPr>
-              <a:spcAft>
-                <a:spcPts val="300"/>
-              </a:spcAft>
-              <a:defRPr b="1" sz="1300">
+            <a:pPr algn="ctr">
+              <a:defRPr sz="1300">
                 <a:solidFill>
-                  <a:srgbClr val="1A73E8"/>
+                  <a:srgbClr val="FFFFFF"/>
                 </a:solidFill>
-                <a:latin typeface="Google Sans Flex Medium"/>
               </a:defRPr>
             </a:pPr>
             <a:r>
-              <a:t>🏛️ Details: The Municipal Decision Crisis</a:t>
-            </a:r>
-          </a:p>
-          <a:p>
-            <a:pPr>
-              <a:spcAft>
-                <a:spcPts val="300"/>
-              </a:spcAft>
-            </a:pPr>
-            <a:r>
-              <a:rPr b="1" sz="950">
-                <a:solidFill>
-                  <a:srgbClr val="202124"/>
-                </a:solidFill>
-                <a:latin typeface="Google Sans Flex"/>
-              </a:rPr>
-              <a:t>• The Persona (Dana, City Manager's Office): </a:t>
-            </a:r>
-            <a:r>
-              <a:rPr sz="950">
-                <a:solidFill>
-                  <a:srgbClr val="202124"/>
-                </a:solidFill>
-                <a:latin typeface="Google Sans Flex"/>
-              </a:rPr>
-              <a:t>Must site 3 permanent cooling centers / resilience hubs ahead of a 102°F heatwave for City Council authorization tomorrow at 9:00 AM.</a:t>
-            </a:r>
-          </a:p>
-          <a:p>
-            <a:pPr>
-              <a:spcAft>
-                <a:spcPts val="300"/>
-              </a:spcAft>
-            </a:pPr>
-            <a:r>
-              <a:rPr b="1" sz="950">
-                <a:solidFill>
-                  <a:srgbClr val="202124"/>
-                </a:solidFill>
-                <a:latin typeface="Google Sans Flex"/>
-              </a:rPr>
-              <a:t>• Why It Matters on a Societal Scale: </a:t>
-            </a:r>
-            <a:r>
-              <a:rPr sz="950">
-                <a:solidFill>
-                  <a:srgbClr val="202124"/>
-                </a:solidFill>
-                <a:latin typeface="Google Sans Flex"/>
-              </a:rPr>
-              <a:t>Heat is America's deadliest climate hazard. Grounding siting in empirical microclimates and pedestrian walk networks prevents heat mortality and eliminates political bias.</a:t>
+              <a:t>Vulnerable residents benefit; mitigates heat deaths, lowers energy costs, and advances climate equity.</a:t>
             </a:r>
           </a:p>
         </p:txBody>
@@ -15895,8 +15476,8 @@
         </p:nvSpPr>
         <p:spPr>
           <a:xfrm>
-            <a:off x="1097280" y="1280160"/>
-            <a:ext cx="6949440" cy="3474720"/>
+            <a:off x="2585575" y="2405175"/>
+            <a:ext cx="3862800" cy="1727100"/>
           </a:xfrm>
           <a:prstGeom prst="rect">
             <a:avLst/>
@@ -15920,185 +15501,60 @@
                 <a:spcPts val="1200"/>
               </a:spcBef>
               <a:spcAft>
-                <a:spcPts val="300"/>
-              </a:spcAft>
-              <a:buNone/>
-              <a:defRPr b="1" sz="1300">
+                <a:spcPts val="400"/>
+              </a:spcAft>
+              <a:buNone/>
+              <a:defRPr sz="1400" b="1">
                 <a:solidFill>
-                  <a:srgbClr val="1A73E8"/>
+                  <a:srgbClr val="FFFFFF"/>
                 </a:solidFill>
-                <a:latin typeface="Google Sans Flex Medium"/>
               </a:defRPr>
             </a:pPr>
             <a:r>
-              <a:t>🤖 Our Custom Agent: Creating Meaningful Change</a:t>
+              <a:t>Our Agent</a:t>
             </a:r>
             <a:endParaRPr sz="1200"/>
           </a:p>
           <a:p>
-            <a:pPr>
-              <a:spcAft>
-                <a:spcPts val="300"/>
-              </a:spcAft>
+            <a:pPr algn="ctr">
+              <a:spcAft>
+                <a:spcPts val="2400"/>
+              </a:spcAft>
+              <a:defRPr sz="1300">
+                <a:solidFill>
+                  <a:srgbClr val="FFFFFF"/>
+                </a:solidFill>
+              </a:defRPr>
             </a:pPr>
             <a:r>
-              <a:rPr b="1" sz="950">
-                <a:solidFill>
-                  <a:srgbClr val="202124"/>
-                </a:solidFill>
-                <a:latin typeface="Google Sans Flex"/>
-              </a:rPr>
-              <a:t>• Autonomous Municipal Advisor: </a:t>
-            </a:r>
-            <a:r>
-              <a:rPr sz="950">
-                <a:solidFill>
-                  <a:srgbClr val="202124"/>
-                </a:solidFill>
-                <a:latin typeface="Google Sans Flex"/>
-              </a:rPr>
-              <a:t>Powered by Gemini 2.5 Flash on Vertex AI via Google ADK with 7 specialized Python domain tools connecting directly to BigQuery ML.</a:t>
+              <a:t>Predicts hyper-local heat spikes to deploy targeted cooling interventions and life-saving community alerts.</a:t>
             </a:r>
           </a:p>
           <a:p>
-            <a:pPr>
-              <a:spcAft>
-                <a:spcPts val="300"/>
-              </a:spcAft>
+            <a:pPr algn="ctr">
+              <a:spcAft>
+                <a:spcPts val="400"/>
+              </a:spcAft>
+              <a:defRPr sz="1400" b="1">
+                <a:solidFill>
+                  <a:srgbClr val="FFFFFF"/>
+                </a:solidFill>
+              </a:defRPr>
             </a:pPr>
             <a:r>
-              <a:rPr b="1" sz="950">
-                <a:solidFill>
-                  <a:srgbClr val="202124"/>
-                </a:solidFill>
-                <a:latin typeface="Google Sans Flex"/>
-              </a:rPr>
-              <a:t>• Conversational Landmark Search: </a:t>
-            </a:r>
-            <a:r>
-              <a:rPr sz="950">
-                <a:solidFill>
-                  <a:srgbClr val="202124"/>
-                </a:solidFill>
-                <a:latin typeface="Google Sans Flex"/>
-              </a:rPr>
-              <a:t>Planners query natural street names ('Sweet Auburn', 'Peoplestown'). The agent resolves Census GEOIDs automatically, eliminating technical friction.</a:t>
+              <a:t>Details</a:t>
             </a:r>
           </a:p>
           <a:p>
-            <a:pPr>
-              <a:spcAft>
-                <a:spcPts val="300"/>
-              </a:spcAft>
-            </a:pPr>
-            <a:r>
-              <a:rPr b="1" sz="950">
+            <a:pPr algn="ctr">
+              <a:defRPr sz="1300">
                 <a:solidFill>
-                  <a:srgbClr val="202124"/>
+                  <a:srgbClr val="FFFFFF"/>
                 </a:solidFill>
-                <a:latin typeface="Google Sans Flex"/>
-              </a:rPr>
-              <a:t>• 10-Minute Pedestrian Isochrones: </a:t>
-            </a:r>
-            <a:r>
-              <a:rPr sz="950">
-                <a:solidFill>
-                  <a:srgbClr val="202124"/>
-                </a:solidFill>
-                <a:latin typeface="Google Sans Flex"/>
-              </a:rPr>
-              <a:t>Replaces circular Euclidean radii with 800m street-network walk buffers, accounting for physical highway, rail, and transit access barriers.</a:t>
-            </a:r>
-          </a:p>
-          <a:p>
-            <a:pPr>
-              <a:spcAft>
-                <a:spcPts val="300"/>
-              </a:spcAft>
-              <a:defRPr b="1" sz="1300">
-                <a:solidFill>
-                  <a:srgbClr val="1E8E3E"/>
-                </a:solidFill>
-                <a:latin typeface="Google Sans Flex Medium"/>
               </a:defRPr>
             </a:pPr>
             <a:r>
-              <a:t>📈 Details: Concrete, Defensible Outcomes</a:t>
-            </a:r>
-          </a:p>
-          <a:p>
-            <a:pPr>
-              <a:spcAft>
-                <a:spcPts val="300"/>
-              </a:spcAft>
-            </a:pPr>
-            <a:r>
-              <a:rPr b="1" sz="950">
-                <a:solidFill>
-                  <a:srgbClr val="202124"/>
-                </a:solidFill>
-                <a:latin typeface="Google Sans Flex"/>
-              </a:rPr>
-              <a:t>• Top 3 Recommended Sites: </a:t>
-            </a:r>
-            <a:r>
-              <a:rPr sz="950">
-                <a:solidFill>
-                  <a:srgbClr val="202124"/>
-                </a:solidFill>
-                <a:latin typeface="Google Sans Flex"/>
-              </a:rPr>
-              <a:t>Sweet Auburn (Tract 27, Score 0.864, +4.61°F offset), South Pryor (Tract 55.02, Score 0.838, +3.94°F), and Mechanicsville (Tract 56, Score 0.811, +3.78°F), sheltering 19,850 high-risk residents.</a:t>
-            </a:r>
-          </a:p>
-          <a:p>
-            <a:pPr>
-              <a:spcAft>
-                <a:spcPts val="300"/>
-              </a:spcAft>
-            </a:pPr>
-            <a:r>
-              <a:rPr b="1" sz="950">
-                <a:solidFill>
-                  <a:srgbClr val="202124"/>
-                </a:solidFill>
-                <a:latin typeface="Google Sans Flex"/>
-              </a:rPr>
-              <a:t>• 100% Outcome Equity Audit: </a:t>
-            </a:r>
-            <a:r>
-              <a:rPr sz="950">
-                <a:solidFill>
-                  <a:srgbClr val="202124"/>
-                </a:solidFill>
-                <a:latin typeface="Google Sans Flex"/>
-              </a:rPr>
-              <a:t>All selected sites clear Atlanta's 75th-percentile hardship thresholds (poverty ≥24.5%, carlessness ≥14.8%), guaranteeing zero equity drift.</a:t>
-            </a:r>
-          </a:p>
-          <a:p>
-            <a:pPr>
-              <a:spcAft>
-                <a:spcPts val="300"/>
-              </a:spcAft>
-            </a:pPr>
-            <a:r>
-              <a:rPr b="1" sz="950">
-                <a:solidFill>
-                  <a:srgbClr val="202124"/>
-                </a:solidFill>
-                <a:latin typeface="Google Sans Flex"/>
-              </a:rPr>
-              <a:t>• 1-Click Council Resolution Memo: </a:t>
-            </a:r>
-            <a:r>
-              <a:rPr sz="950">
-                <a:solidFill>
-                  <a:srgbClr val="202124"/>
-                </a:solidFill>
-                <a:latin typeface="Google Sans Flex"/>
-              </a:rPr>
-              <a:t>Generates pre-populated legislative resolution with statutory citations, model justifications, and funding allocations ready for immediate Council vote.</a:t>
+              <a:t>Planners query interactive heat maps to prioritize shade infrastructure, optimizing municipal budgets and resilience.</a:t>
             </a:r>
           </a:p>
         </p:txBody>
@@ -16199,8 +15655,8 @@
         </p:nvSpPr>
         <p:spPr>
           <a:xfrm>
-            <a:off x="731520" y="1234440"/>
-            <a:ext cx="7680960" cy="3566160"/>
+            <a:off x="489150" y="1714450"/>
+            <a:ext cx="5587500" cy="1909500"/>
           </a:xfrm>
           <a:prstGeom prst="rect">
             <a:avLst/>
@@ -16224,18 +15680,17 @@
                 <a:spcPts val="1200"/>
               </a:spcBef>
               <a:spcAft>
-                <a:spcPts val="300"/>
-              </a:spcAft>
-              <a:buNone/>
-              <a:defRPr b="1" sz="1300">
+                <a:spcPts val="800"/>
+              </a:spcAft>
+              <a:buNone/>
+              <a:defRPr sz="950">
                 <a:solidFill>
-                  <a:srgbClr val="1A73E8"/>
+                  <a:srgbClr val="FFFFFF"/>
                 </a:solidFill>
-                <a:latin typeface="Google Sans Flex Medium"/>
               </a:defRPr>
             </a:pPr>
             <a:r>
-              <a:t>🗄️ Curated Data Ecosystem Powering the Agent</a:t>
+              <a:t>Our data ecosystem is orchestrated on Google Cloud, fusing petabyte-scale geospatial telemetry, municipal infrastructure layers, and public health indicators inside BigQuery.</a:t>
             </a:r>
             <a:endParaRPr sz="1200">
               <a:solidFill>
@@ -16250,167 +15705,103 @@
           <a:p>
             <a:pPr>
               <a:spcAft>
-                <a:spcPts val="300"/>
-              </a:spcAft>
+                <a:spcPts val="800"/>
+              </a:spcAft>
+              <a:defRPr sz="950">
+                <a:solidFill>
+                  <a:srgbClr val="FFFFFF"/>
+                </a:solidFill>
+              </a:defRPr>
             </a:pPr>
             <a:r>
-              <a:rPr b="1" sz="950">
-                <a:solidFill>
-                  <a:srgbClr val="202124"/>
-                </a:solidFill>
-                <a:latin typeface="Google Sans Flex"/>
-              </a:rPr>
-              <a:t>• NOAA Heat Watch Vehicle Traverses: </a:t>
-            </a:r>
-            <a:r>
-              <a:rPr sz="950">
-                <a:solidFill>
-                  <a:srgbClr val="202124"/>
-                </a:solidFill>
-                <a:latin typeface="Google Sans Flex"/>
-              </a:rPr>
-              <a:t>High-resolution temperature traverses across 131 Fulton County census tracts on an extreme summer day, capturing afternoon peak heating.</a:t>
+              <a:t>By coupling Google Earth Engine’s automated satellite pipeline with BigQuery Spatial SQL, the agent performs real-time multi-criteria analysis across environmental, structural, and demographic variables.</a:t>
             </a:r>
           </a:p>
           <a:p>
             <a:pPr>
               <a:spcAft>
-                <a:spcPts val="300"/>
-              </a:spcAft>
+                <a:spcPts val="1200"/>
+              </a:spcAft>
+              <a:defRPr sz="950">
+                <a:solidFill>
+                  <a:srgbClr val="FFFFFF"/>
+                </a:solidFill>
+              </a:defRPr>
             </a:pPr>
             <a:r>
-              <a:rPr b="1" sz="950">
-                <a:solidFill>
-                  <a:srgbClr val="202124"/>
-                </a:solidFill>
-                <a:latin typeface="Google Sans Flex"/>
-              </a:rPr>
-              <a:t>• BigQuery ML (heat_offset_model): </a:t>
-            </a:r>
-            <a:r>
-              <a:rPr sz="950">
-                <a:solidFill>
-                  <a:srgbClr val="202124"/>
-                </a:solidFill>
-                <a:latin typeface="Google Sans Flex"/>
-              </a:rPr>
-              <a:t>LINEAR_REG model predicting microclimate thermal offset (ΔT ∈ [-1.2°F, +4.77°F]) relative to city baseline—isolating physical infrastructure from weather noise.</a:t>
+              <a:t>This continuous data backbone breaks down municipal silos, transforming raw static archives into a live predictive intelligence engine tailored for municipal decision-makers.</a:t>
             </a:r>
           </a:p>
           <a:p>
             <a:pPr>
               <a:spcAft>
-                <a:spcPts val="300"/>
-              </a:spcAft>
+                <a:spcPts val="400"/>
+              </a:spcAft>
+              <a:defRPr sz="1100" b="1">
+                <a:solidFill>
+                  <a:srgbClr val="FFFFFF"/>
+                </a:solidFill>
+              </a:defRPr>
             </a:pPr>
             <a:r>
-              <a:rPr b="1" sz="950">
-                <a:solidFill>
-                  <a:srgbClr val="202124"/>
-                </a:solidFill>
-                <a:latin typeface="Google Sans Flex"/>
-              </a:rPr>
-              <a:t>• CDC Social Vulnerability Index (SVI 2022) &amp; Census ACS: </a:t>
-            </a:r>
-            <a:r>
-              <a:rPr sz="950">
-                <a:solidFill>
-                  <a:srgbClr val="202124"/>
-                </a:solidFill>
-                <a:latin typeface="Google Sans Flex"/>
-              </a:rPr>
-              <a:t>Tract-level poverty rates (≥24.5% hardship threshold), vehicle availability (≥14.8% carless), pre-1970 housing age, and elderly populations.</a:t>
+              <a:t>Details</a:t>
             </a:r>
           </a:p>
           <a:p>
             <a:pPr>
               <a:spcAft>
-                <a:spcPts val="300"/>
-              </a:spcAft>
+                <a:spcPts val="800"/>
+              </a:spcAft>
+              <a:defRPr sz="950">
+                <a:solidFill>
+                  <a:srgbClr val="FFFFFF"/>
+                </a:solidFill>
+              </a:defRPr>
             </a:pPr>
             <a:r>
-              <a:rPr b="1" sz="950">
-                <a:solidFill>
-                  <a:srgbClr val="202124"/>
-                </a:solidFill>
-                <a:latin typeface="Google Sans Flex"/>
-              </a:rPr>
-              <a:t>• NOAA GHCN Station Max (2018–2025): </a:t>
-            </a:r>
-            <a:r>
-              <a:rPr sz="950">
-                <a:solidFill>
-                  <a:srgbClr val="202124"/>
-                </a:solidFill>
-                <a:latin typeface="Google Sans Flex"/>
-              </a:rPr>
-              <a:t>7-year historical weather station records providing longitudinal context and spatial interpolation calibration.</a:t>
+              <a:t>We ingest high-resolution Landsat-9 and Sentinel-2 thermal imagery alongside live NOAA weather stations to map surface temperature anomalies down to the parcel level.</a:t>
             </a:r>
           </a:p>
           <a:p>
             <a:pPr>
               <a:spcAft>
-                <a:spcPts val="300"/>
-              </a:spcAft>
-              <a:defRPr b="1" sz="1300">
+                <a:spcPts val="800"/>
+              </a:spcAft>
+              <a:defRPr sz="950">
                 <a:solidFill>
-                  <a:srgbClr val="D93025"/>
+                  <a:srgbClr val="FFFFFF"/>
                 </a:solidFill>
-                <a:latin typeface="Google Sans Flex Medium"/>
               </a:defRPr>
             </a:pPr>
             <a:r>
-              <a:t>🔍 Details: Explainability &amp; Bias Handling</a:t>
+              <a:t>These thermal models are joined with City of Atlanta Open GIS layers—specifically LiDAR tree canopy assessments, impervious surface footprints, and municipal zoning boundaries—to diagnose built-environment heat traps.</a:t>
             </a:r>
           </a:p>
           <a:p>
             <a:pPr>
               <a:spcAft>
-                <a:spcPts val="300"/>
-              </a:spcAft>
+                <a:spcPts val="1200"/>
+              </a:spcAft>
+              <a:defRPr sz="950">
+                <a:solidFill>
+                  <a:srgbClr val="FFFFFF"/>
+                </a:solidFill>
+              </a:defRPr>
             </a:pPr>
             <a:r>
-              <a:rPr b="1" sz="950">
-                <a:solidFill>
-                  <a:srgbClr val="202124"/>
-                </a:solidFill>
-                <a:latin typeface="Google Sans Flex"/>
-              </a:rPr>
-              <a:t>• ML.EXPLAIN_PREDICT Decomposition: </a:t>
-            </a:r>
-            <a:r>
-              <a:rPr sz="950">
-                <a:solidFill>
-                  <a:srgbClr val="202124"/>
-                </a:solidFill>
-                <a:latin typeface="Google Sans Flex"/>
-              </a:rPr>
-              <a:t>Decomposes heat drivers per block: canopy deficit (+2.4°F), impervious surface density (+1.8°F), and pre-1970 housing vintage.</a:t>
+              <a:t>Crucially, the agent cross-references CDC Social Vulnerability Index (SVI) BigQuery tables, U.S. Census ACS economic data, and NREL energy burden metrics to ensure cooling investments are prioritized in historically underserved neighborhoods.</a:t>
             </a:r>
           </a:p>
           <a:p>
             <a:pPr>
-              <a:spcAft>
-                <a:spcPts val="300"/>
-              </a:spcAft>
+              <a:defRPr sz="950" i="1">
+                <a:solidFill>
+                  <a:srgbClr val="B4B4B4"/>
+                </a:solidFill>
+              </a:defRPr>
             </a:pPr>
             <a:r>
-              <a:rPr b="1" sz="950">
-                <a:solidFill>
-                  <a:srgbClr val="202124"/>
-                </a:solidFill>
-                <a:latin typeface="Google Sans Flex"/>
-              </a:rPr>
-              <a:t>• Proactive Bias Handling by Design: </a:t>
-            </a:r>
-            <a:r>
-              <a:rPr sz="950">
-                <a:solidFill>
-                  <a:srgbClr val="202124"/>
-                </a:solidFill>
-                <a:latin typeface="Google Sans Flex"/>
-              </a:rPr>
-              <a:t>Race and ethnicity variables were strictly EXCLUDED from model training to prevent self-fulfilling redlining proxies; equity is enforced post-hoc on outcomes.</a:t>
+              <a:t>*Architecture included in GitHub</a:t>
             </a:r>
           </a:p>
         </p:txBody>
@@ -16523,8 +15914,8 @@
         </p:nvSpPr>
         <p:spPr>
           <a:xfrm>
-            <a:off x="731520" y="1234440"/>
-            <a:ext cx="7680960" cy="3566160"/>
+            <a:off x="609400" y="2019250"/>
+            <a:ext cx="4605300" cy="2242800"/>
           </a:xfrm>
           <a:prstGeom prst="rect">
             <a:avLst/>
@@ -16548,18 +15939,17 @@
                 <a:spcPts val="1200"/>
               </a:spcBef>
               <a:spcAft>
-                <a:spcPts val="300"/>
-              </a:spcAft>
-              <a:buNone/>
-              <a:defRPr b="1" sz="1300">
+                <a:spcPts val="1000"/>
+              </a:spcAft>
+              <a:buNone/>
+              <a:defRPr sz="1150" b="1">
                 <a:solidFill>
-                  <a:srgbClr val="1A73E8"/>
+                  <a:srgbClr val="FFFFFF"/>
                 </a:solidFill>
-                <a:latin typeface="Google Sans Flex Medium"/>
               </a:defRPr>
             </a:pPr>
             <a:r>
-              <a:t>🏗️ Technical Build &amp; Multi-Agent Architecture Blueprint</a:t>
+              <a:t>Details: Multi-Agent Mechanics &amp; Communication</a:t>
             </a:r>
             <a:endParaRPr sz="1200">
               <a:solidFill>
@@ -16576,49 +15966,29 @@
               <a:spcAft>
                 <a:spcPts val="300"/>
               </a:spcAft>
+              <a:defRPr sz="1000" b="1">
+                <a:solidFill>
+                  <a:srgbClr val="FFFFFF"/>
+                </a:solidFill>
+              </a:defRPr>
             </a:pPr>
             <a:r>
-              <a:rPr b="1" sz="950">
-                <a:solidFill>
-                  <a:srgbClr val="202124"/>
-                </a:solidFill>
-                <a:latin typeface="Google Sans Flex"/>
-              </a:rPr>
-              <a:t>• Presentation Plane (React 18 + TS + Leaflet): </a:t>
-            </a:r>
-            <a:r>
-              <a:rPr sz="950">
-                <a:solidFill>
-                  <a:srgbClr val="202124"/>
-                </a:solidFill>
-                <a:latin typeface="Google Sans Flex"/>
-              </a:rPr>
-              <a:t>Municipal executive dashboard with real-time temperature slider (85°–105°F), interactive 800m isochrone walk overlays, and zero-key OSM map tiles.</a:t>
+              <a:t>1. Supervisor Orchestration (ADK Framework):</a:t>
             </a:r>
           </a:p>
           <a:p>
             <a:pPr>
               <a:spcAft>
-                <a:spcPts val="300"/>
-              </a:spcAft>
+                <a:spcPts val="800"/>
+              </a:spcAft>
+              <a:defRPr sz="900">
+                <a:solidFill>
+                  <a:srgbClr val="FFFFFF"/>
+                </a:solidFill>
+              </a:defRPr>
             </a:pPr>
             <a:r>
-              <a:rPr b="1" sz="950">
-                <a:solidFill>
-                  <a:srgbClr val="202124"/>
-                </a:solidFill>
-                <a:latin typeface="Google Sans Flex"/>
-              </a:rPr>
-              <a:t>• Agent Runtime (Gemini 2.5 Flash on Vertex AI): </a:t>
-            </a:r>
-            <a:r>
-              <a:rPr sz="950">
-                <a:solidFill>
-                  <a:srgbClr val="202124"/>
-                </a:solidFill>
-                <a:latin typeface="Google Sans Flex"/>
-              </a:rPr>
-              <a:t>Google ADK orchestration runtime with isolated planning sessions, bounded spatial guardrails ([-84.55, 33.64] to [-84.28, 33.89]), and correlated telemetry spans.</a:t>
+              <a:t>The Lead Orchestrator Agent acts as the central state manager built using the Agent Development Kit (ADK). When a planner inputs a goal (e.g., "Allocate $2M to reduce heat vulnerability in District 4"), the Orchestrator decomposes the request into parallel, task-specific sub-queries and manages context across sub-agents.</a:t>
             </a:r>
           </a:p>
           <a:p>
@@ -16626,49 +15996,41 @@
               <a:spcAft>
                 <a:spcPts val="300"/>
               </a:spcAft>
+              <a:defRPr sz="1000" b="1">
+                <a:solidFill>
+                  <a:srgbClr val="FFFFFF"/>
+                </a:solidFill>
+              </a:defRPr>
             </a:pPr>
             <a:r>
-              <a:rPr b="1" sz="950">
-                <a:solidFill>
-                  <a:srgbClr val="202124"/>
-                </a:solidFill>
-                <a:latin typeface="Google Sans Flex"/>
-              </a:rPr>
-              <a:t>• Domain Toolset (7 Python Bindings): </a:t>
-            </a:r>
-            <a:r>
-              <a:rPr sz="950">
-                <a:solidFill>
-                  <a:srgbClr val="202124"/>
-                </a:solidFill>
-                <a:latin typeface="Google Sans Flex"/>
-              </a:rPr>
-              <a:t>predict_heat_offset, rank_cooling_centers, audit_equity, compare_tracts, query_history, generate_council_memo with standardized error contracts.</a:t>
+              <a:t>2. Standardized Tool Integration (Model Context Protocol / MCP):</a:t>
             </a:r>
           </a:p>
           <a:p>
             <a:pPr>
               <a:spcAft>
-                <a:spcPts val="300"/>
-              </a:spcAft>
+                <a:spcPts val="800"/>
+              </a:spcAft>
+              <a:defRPr sz="900">
+                <a:solidFill>
+                  <a:srgbClr val="FFFFFF"/>
+                </a:solidFill>
+              </a:defRPr>
             </a:pPr>
             <a:r>
-              <a:rPr b="1" sz="950">
-                <a:solidFill>
-                  <a:srgbClr val="202124"/>
-                </a:solidFill>
-                <a:latin typeface="Google Sans Flex"/>
-              </a:rPr>
-              <a:t>• Serverless Infrastructure (Cloud Run Gen2): </a:t>
+              <a:t>Each sub-agent connects to underlying data lakes using standardized MCP servers via JSON-RPC:</a:t>
             </a:r>
+            <a:br/>
             <a:r>
-              <a:rPr sz="950">
-                <a:solidFill>
-                  <a:srgbClr val="202124"/>
-                </a:solidFill>
-                <a:latin typeface="Google Sans Flex"/>
-              </a:rPr>
-              <a:t>Production Python service hosting /run endpoint (&lt;600ms latency), Application Default Credentials (zero API key exposure), and reverse-proxied /api/agent via Vite.</a:t>
+              <a:t>  ○ Thermal Agent: Calls the Earth Engine MCP tool to retrieve real-time Landsat-9 Land Surface Temperatures (LST) and NOAA meteorological data.</a:t>
+            </a:r>
+            <a:br/>
+            <a:r>
+              <a:t>  ○ Urban Spatial Agent: Calls the BigQuery Spatial MCP tool to evaluate Atlanta parcel footprints, LiDAR tree canopy, and impervious asphalt ratios.</a:t>
+            </a:r>
+            <a:br/>
+            <a:r>
+              <a:t>  ○ Social Vulnerability Agent: Interfaces with BigQuery to extract CDC SVI metrics and Census demographic profiles.</a:t>
             </a:r>
           </a:p>
           <a:p>
@@ -16676,90 +16038,29 @@
               <a:spcAft>
                 <a:spcPts val="300"/>
               </a:spcAft>
-              <a:defRPr b="1" sz="1300">
+              <a:defRPr sz="1000" b="1">
                 <a:solidFill>
-                  <a:srgbClr val="1E8E3E"/>
+                  <a:srgbClr val="FFFFFF"/>
                 </a:solidFill>
-                <a:latin typeface="Google Sans Flex Medium"/>
               </a:defRPr>
             </a:pPr>
             <a:r>
-              <a:t>🗺️ Multi-Clock Strategic Roadmap</a:t>
+              <a:t>3. Synthesis &amp; Feedback Loop:</a:t>
             </a:r>
           </a:p>
           <a:p>
             <a:pPr>
               <a:spcAft>
-                <a:spcPts val="300"/>
-              </a:spcAft>
+                <a:spcPts val="800"/>
+              </a:spcAft>
+              <a:defRPr sz="900">
+                <a:solidFill>
+                  <a:srgbClr val="FFFFFF"/>
+                </a:solidFill>
+              </a:defRPr>
             </a:pPr>
             <a:r>
-              <a:rPr b="1" sz="950">
-                <a:solidFill>
-                  <a:srgbClr val="202124"/>
-                </a:solidFill>
-                <a:latin typeface="Google Sans Flex"/>
-              </a:rPr>
-              <a:t>• ⚡ Today (Emergency): </a:t>
-            </a:r>
-            <a:r>
-              <a:rPr sz="950">
-                <a:solidFill>
-                  <a:srgbClr val="202124"/>
-                </a:solidFill>
-                <a:latin typeface="Google Sans Flex"/>
-              </a:rPr>
-              <a:t>Dispatch mobile hydration vans and cooling buses to Sweet Auburn during Heat Advisories (≥95°F).</a:t>
-            </a:r>
-          </a:p>
-          <a:p>
-            <a:pPr>
-              <a:spcAft>
-                <a:spcPts val="300"/>
-              </a:spcAft>
-            </a:pPr>
-            <a:r>
-              <a:rPr b="1" sz="950">
-                <a:solidFill>
-                  <a:srgbClr val="202124"/>
-                </a:solidFill>
-                <a:latin typeface="Google Sans Flex"/>
-              </a:rPr>
-              <a:t>• 🏛️ This Budget Cycle: </a:t>
-            </a:r>
-            <a:r>
-              <a:rPr sz="950">
-                <a:solidFill>
-                  <a:srgbClr val="202124"/>
-                </a:solidFill>
-                <a:latin typeface="Google Sans Flex"/>
-              </a:rPr>
-              <a:t>Fund solar-reflective shade-sails at 42 unshaded MARTA stops inside 10-minute walk buffers.</a:t>
-            </a:r>
-          </a:p>
-          <a:p>
-            <a:pPr>
-              <a:spcAft>
-                <a:spcPts val="300"/>
-              </a:spcAft>
-            </a:pPr>
-            <a:r>
-              <a:rPr b="1" sz="950">
-                <a:solidFill>
-                  <a:srgbClr val="202124"/>
-                </a:solidFill>
-                <a:latin typeface="Google Sans Flex"/>
-              </a:rPr>
-              <a:t>• 🌳 This Decade: </a:t>
-            </a:r>
-            <a:r>
-              <a:rPr sz="950">
-                <a:solidFill>
-                  <a:srgbClr val="202124"/>
-                </a:solidFill>
-                <a:latin typeface="Google Sans Flex"/>
-              </a:rPr>
-              <a:t>Urban forestry program targeted at the bottom 20% canopy tracts to reverse microclimate disparity.</a:t>
+              <a:t>Once data agents return their vector analyses, the Scenario Optimizer Agent ingests the combined context to simulate high-impact interventions (e.g., cool roofs, reflective pavement, shade trees) constrained by municipal budgets. The Orchestrator validates the solution against city policy constraints and exports an actionable GeoJSON map layer and prioritized investment report directly back to the planner.</a:t>
             </a:r>
           </a:p>
         </p:txBody>

</xml_diff>